<commit_message>
Reorder projects by importance, wire 3 event videos, add Darin Madani project
Co-Authored-By: Claude Opus 4.8 <noreply@anthropic.com>
</commit_message>
<xml_diff>
--- a/Jad’s Profile.pptx
+++ b/Jad’s Profile.pptx
@@ -21,6 +21,7 @@
     <p:sldId id="269" r:id="rId15"/>
     <p:sldId id="270" r:id="rId16"/>
     <p:sldId id="271" r:id="rId17"/>
+    <p:sldId id="272" r:id="rId18"/>
   </p:sldIdLst>
   <p:sldSz cx="12192000" cy="6858000"/>
   <p:notesSz cx="6858000" cy="9144000"/>
@@ -119,13 +120,18 @@
       </a:defRPr>
     </a:lvl9pPr>
   </p:defaultTextStyle>
+  <p:extLst>
+    <p:ext uri="{EFAFB233-063F-42B5-8137-9DF3F51BA10A}">
+      <p15:sldGuideLst xmlns:p15="http://schemas.microsoft.com/office/powerpoint/2012/main"/>
+    </p:ext>
+  </p:extLst>
 </p:presentation>
 </file>
 
 <file path=ppt/revisionInfo.xml><?xml version="1.0" encoding="utf-8"?>
 <p1510:revInfo xmlns:a="http://schemas.openxmlformats.org/drawingml/2006/main" xmlns:r="http://schemas.openxmlformats.org/officeDocument/2006/relationships" xmlns:p1510="http://schemas.microsoft.com/office/powerpoint/2015/10/main">
   <p1510:revLst>
-    <p1510:client id="{DBEE4B2F-CEBB-4CB8-BCF1-8A957D2D5D2C}" v="18" dt="2026-06-07T15:41:44.174"/>
+    <p1510:client id="{DBEE4B2F-CEBB-4CB8-BCF1-8A957D2D5D2C}" v="19" dt="2026-06-08T07:08:39.604"/>
   </p1510:revLst>
 </p1510:revInfo>
 </file>
@@ -135,7 +141,7 @@
   <pc:docChgLst>
     <pc:chgData name="jad assaf" userId="99cc43a20e8f553c" providerId="LiveId" clId="{E44C0D75-47FD-41BB-AE10-9C245BD6675C}"/>
     <pc:docChg chg="undo custSel addSld modSld">
-      <pc:chgData name="jad assaf" userId="99cc43a20e8f553c" providerId="LiveId" clId="{E44C0D75-47FD-41BB-AE10-9C245BD6675C}" dt="2026-06-07T15:41:47.470" v="432" actId="404"/>
+      <pc:chgData name="jad assaf" userId="99cc43a20e8f553c" providerId="LiveId" clId="{E44C0D75-47FD-41BB-AE10-9C245BD6675C}" dt="2026-06-08T07:08:43.898" v="470" actId="404"/>
       <pc:docMkLst>
         <pc:docMk/>
       </pc:docMkLst>
@@ -430,6 +436,29 @@
           </ac:spMkLst>
         </pc:spChg>
       </pc:sldChg>
+      <pc:sldChg chg="modSp new mod">
+        <pc:chgData name="jad assaf" userId="99cc43a20e8f553c" providerId="LiveId" clId="{E44C0D75-47FD-41BB-AE10-9C245BD6675C}" dt="2026-06-08T07:08:43.898" v="470" actId="404"/>
+        <pc:sldMkLst>
+          <pc:docMk/>
+          <pc:sldMk cId="3561657796" sldId="272"/>
+        </pc:sldMkLst>
+        <pc:spChg chg="mod">
+          <ac:chgData name="jad assaf" userId="99cc43a20e8f553c" providerId="LiveId" clId="{E44C0D75-47FD-41BB-AE10-9C245BD6675C}" dt="2026-06-08T06:58:35.684" v="463" actId="20577"/>
+          <ac:spMkLst>
+            <pc:docMk/>
+            <pc:sldMk cId="3561657796" sldId="272"/>
+            <ac:spMk id="2" creationId="{ED5F326C-C848-BA3D-11B2-E835161FEA37}"/>
+          </ac:spMkLst>
+        </pc:spChg>
+        <pc:spChg chg="mod">
+          <ac:chgData name="jad assaf" userId="99cc43a20e8f553c" providerId="LiveId" clId="{E44C0D75-47FD-41BB-AE10-9C245BD6675C}" dt="2026-06-08T07:08:43.898" v="470" actId="404"/>
+          <ac:spMkLst>
+            <pc:docMk/>
+            <pc:sldMk cId="3561657796" sldId="272"/>
+            <ac:spMk id="3" creationId="{F2FAB519-6BF6-D006-81FB-0E27FB6D2E1B}"/>
+          </ac:spMkLst>
+        </pc:spChg>
+      </pc:sldChg>
     </pc:docChg>
   </pc:docChgLst>
 </pc:chgInfo>
@@ -582,7 +611,7 @@
           <a:p>
             <a:fld id="{AB13387E-4479-41F6-9EBE-72CEB6FF5A19}" type="datetimeFigureOut">
               <a:rPr lang="en-US" smtClean="0"/>
-              <a:t>07-Jun-26</a:t>
+              <a:t>08-Jun-26</a:t>
             </a:fld>
             <a:endParaRPr lang="en-US"/>
           </a:p>
@@ -780,7 +809,7 @@
           <a:p>
             <a:fld id="{AB13387E-4479-41F6-9EBE-72CEB6FF5A19}" type="datetimeFigureOut">
               <a:rPr lang="en-US" smtClean="0"/>
-              <a:t>07-Jun-26</a:t>
+              <a:t>08-Jun-26</a:t>
             </a:fld>
             <a:endParaRPr lang="en-US"/>
           </a:p>
@@ -988,7 +1017,7 @@
           <a:p>
             <a:fld id="{AB13387E-4479-41F6-9EBE-72CEB6FF5A19}" type="datetimeFigureOut">
               <a:rPr lang="en-US" smtClean="0"/>
-              <a:t>07-Jun-26</a:t>
+              <a:t>08-Jun-26</a:t>
             </a:fld>
             <a:endParaRPr lang="en-US"/>
           </a:p>
@@ -1186,7 +1215,7 @@
           <a:p>
             <a:fld id="{AB13387E-4479-41F6-9EBE-72CEB6FF5A19}" type="datetimeFigureOut">
               <a:rPr lang="en-US" smtClean="0"/>
-              <a:t>07-Jun-26</a:t>
+              <a:t>08-Jun-26</a:t>
             </a:fld>
             <a:endParaRPr lang="en-US"/>
           </a:p>
@@ -1461,7 +1490,7 @@
           <a:p>
             <a:fld id="{AB13387E-4479-41F6-9EBE-72CEB6FF5A19}" type="datetimeFigureOut">
               <a:rPr lang="en-US" smtClean="0"/>
-              <a:t>07-Jun-26</a:t>
+              <a:t>08-Jun-26</a:t>
             </a:fld>
             <a:endParaRPr lang="en-US"/>
           </a:p>
@@ -1726,7 +1755,7 @@
           <a:p>
             <a:fld id="{AB13387E-4479-41F6-9EBE-72CEB6FF5A19}" type="datetimeFigureOut">
               <a:rPr lang="en-US" smtClean="0"/>
-              <a:t>07-Jun-26</a:t>
+              <a:t>08-Jun-26</a:t>
             </a:fld>
             <a:endParaRPr lang="en-US"/>
           </a:p>
@@ -2138,7 +2167,7 @@
           <a:p>
             <a:fld id="{AB13387E-4479-41F6-9EBE-72CEB6FF5A19}" type="datetimeFigureOut">
               <a:rPr lang="en-US" smtClean="0"/>
-              <a:t>07-Jun-26</a:t>
+              <a:t>08-Jun-26</a:t>
             </a:fld>
             <a:endParaRPr lang="en-US"/>
           </a:p>
@@ -2279,7 +2308,7 @@
           <a:p>
             <a:fld id="{AB13387E-4479-41F6-9EBE-72CEB6FF5A19}" type="datetimeFigureOut">
               <a:rPr lang="en-US" smtClean="0"/>
-              <a:t>07-Jun-26</a:t>
+              <a:t>08-Jun-26</a:t>
             </a:fld>
             <a:endParaRPr lang="en-US"/>
           </a:p>
@@ -2392,7 +2421,7 @@
           <a:p>
             <a:fld id="{AB13387E-4479-41F6-9EBE-72CEB6FF5A19}" type="datetimeFigureOut">
               <a:rPr lang="en-US" smtClean="0"/>
-              <a:t>07-Jun-26</a:t>
+              <a:t>08-Jun-26</a:t>
             </a:fld>
             <a:endParaRPr lang="en-US"/>
           </a:p>
@@ -2703,7 +2732,7 @@
           <a:p>
             <a:fld id="{AB13387E-4479-41F6-9EBE-72CEB6FF5A19}" type="datetimeFigureOut">
               <a:rPr lang="en-US" smtClean="0"/>
-              <a:t>07-Jun-26</a:t>
+              <a:t>08-Jun-26</a:t>
             </a:fld>
             <a:endParaRPr lang="en-US"/>
           </a:p>
@@ -2991,7 +3020,7 @@
           <a:p>
             <a:fld id="{AB13387E-4479-41F6-9EBE-72CEB6FF5A19}" type="datetimeFigureOut">
               <a:rPr lang="en-US" smtClean="0"/>
-              <a:t>07-Jun-26</a:t>
+              <a:t>08-Jun-26</a:t>
             </a:fld>
             <a:endParaRPr lang="en-US"/>
           </a:p>
@@ -3232,7 +3261,7 @@
           <a:p>
             <a:fld id="{AB13387E-4479-41F6-9EBE-72CEB6FF5A19}" type="datetimeFigureOut">
               <a:rPr lang="en-US" smtClean="0"/>
-              <a:t>07-Jun-26</a:t>
+              <a:t>08-Jun-26</a:t>
             </a:fld>
             <a:endParaRPr lang="en-US"/>
           </a:p>
@@ -5293,6 +5322,151 @@
     <p:extLst>
       <p:ext uri="{BB962C8B-B14F-4D97-AF65-F5344CB8AC3E}">
         <p14:creationId xmlns:p14="http://schemas.microsoft.com/office/powerpoint/2010/main" val="3304276469"/>
+      </p:ext>
+    </p:extLst>
+  </p:cSld>
+  <p:clrMapOvr>
+    <a:masterClrMapping/>
+  </p:clrMapOvr>
+</p:sld>
+</file>
+
+<file path=ppt/slides/slide17.xml><?xml version="1.0" encoding="utf-8"?>
+<p:sld xmlns:a="http://schemas.openxmlformats.org/drawingml/2006/main" xmlns:r="http://schemas.openxmlformats.org/officeDocument/2006/relationships" xmlns:p="http://schemas.openxmlformats.org/presentationml/2006/main">
+  <p:cSld>
+    <p:spTree>
+      <p:nvGrpSpPr>
+        <p:cNvPr id="1" name=""/>
+        <p:cNvGrpSpPr/>
+        <p:nvPr/>
+      </p:nvGrpSpPr>
+      <p:grpSpPr>
+        <a:xfrm>
+          <a:off x="0" y="0"/>
+          <a:ext cx="0" cy="0"/>
+          <a:chOff x="0" y="0"/>
+          <a:chExt cx="0" cy="0"/>
+        </a:xfrm>
+      </p:grpSpPr>
+      <p:sp>
+        <p:nvSpPr>
+          <p:cNvPr id="2" name="Title 1">
+            <a:extLst>
+              <a:ext uri="{FF2B5EF4-FFF2-40B4-BE49-F238E27FC236}">
+                <a16:creationId xmlns:a16="http://schemas.microsoft.com/office/drawing/2014/main" id="{ED5F326C-C848-BA3D-11B2-E835161FEA37}"/>
+              </a:ext>
+            </a:extLst>
+          </p:cNvPr>
+          <p:cNvSpPr>
+            <a:spLocks noGrp="1"/>
+          </p:cNvSpPr>
+          <p:nvPr>
+            <p:ph type="title"/>
+          </p:nvPr>
+        </p:nvSpPr>
+        <p:spPr/>
+        <p:txBody>
+          <a:bodyPr/>
+          <a:lstStyle/>
+          <a:p>
+            <a:r>
+              <a:rPr lang="en-US" dirty="0"/>
+              <a:t>Darin Madani Boutique Opening </a:t>
+            </a:r>
+          </a:p>
+        </p:txBody>
+      </p:sp>
+      <p:sp>
+        <p:nvSpPr>
+          <p:cNvPr id="3" name="Content Placeholder 2">
+            <a:extLst>
+              <a:ext uri="{FF2B5EF4-FFF2-40B4-BE49-F238E27FC236}">
+                <a16:creationId xmlns:a16="http://schemas.microsoft.com/office/drawing/2014/main" id="{F2FAB519-6BF6-D006-81FB-0E27FB6D2E1B}"/>
+              </a:ext>
+            </a:extLst>
+          </p:cNvPr>
+          <p:cNvSpPr>
+            <a:spLocks noGrp="1"/>
+          </p:cNvSpPr>
+          <p:nvPr>
+            <p:ph idx="1"/>
+          </p:nvPr>
+        </p:nvSpPr>
+        <p:spPr/>
+        <p:txBody>
+          <a:bodyPr>
+            <a:normAutofit/>
+          </a:bodyPr>
+          <a:lstStyle/>
+          <a:p>
+            <a:r>
+              <a:rPr lang="en-US" sz="1100" b="1" dirty="0"/>
+              <a:t>Client:</a:t>
+            </a:r>
+            <a:r>
+              <a:rPr lang="en-US" sz="1100" dirty="0"/>
+              <a:t> Darin Madani</a:t>
+            </a:r>
+          </a:p>
+          <a:p>
+            <a:r>
+              <a:rPr lang="en-US" sz="1100" b="1" dirty="0"/>
+              <a:t>Location:</a:t>
+            </a:r>
+            <a:r>
+              <a:rPr lang="en-US" sz="1100" dirty="0"/>
+              <a:t> Jeddah, Saudi Arabia</a:t>
+            </a:r>
+          </a:p>
+          <a:p>
+            <a:r>
+              <a:rPr lang="en-US" sz="1100" b="1" dirty="0"/>
+              <a:t>Role:</a:t>
+            </a:r>
+            <a:r>
+              <a:rPr lang="en-US" sz="1100" dirty="0"/>
+              <a:t> Project Manager</a:t>
+            </a:r>
+          </a:p>
+          <a:p>
+            <a:r>
+              <a:rPr lang="en-US" sz="1100" dirty="0"/>
+              <a:t>Led the end-to-end planning, production, and execution of the grand opening of Darin Madani’s fashion boutique and exclusive private fashion showcase in Jeddah, attended by more than 150 high-profile guests, celebrities, influencers, media representatives, and key figures from across the Arab world.</a:t>
+            </a:r>
+          </a:p>
+          <a:p>
+            <a:r>
+              <a:rPr lang="en-US" sz="1100" dirty="0"/>
+              <a:t>Managed all project workstreams from concept development through final delivery, overseeing event operations, production, logistics, client servicing, creative execution, and stakeholder coordination. Directed the launch event experience, boutique activation, fashion show production, VIP guest journey, entertainment program, and private dinner experience.</a:t>
+            </a:r>
+          </a:p>
+          <a:p>
+            <a:r>
+              <a:rPr lang="en-US" sz="1100" dirty="0"/>
+              <a:t>Responsible for coordinating and managing all event elements including fashion show operations, model management, hair and makeup teams, backstage coordination, entertainment performances, DJ programming, audiovisual production (sound, lighting, LED screens, and technical requirements), custom woodwork and event fabrication, branding installations, venue preparation, catering operations, photography and videography coverage, and guest experience execution.</a:t>
+            </a:r>
+          </a:p>
+          <a:p>
+            <a:r>
+              <a:rPr lang="en-US" sz="1100" dirty="0"/>
+              <a:t>Served as the primary client contact, ensuring Darin Madani’s vision was successfully translated into a seamless luxury experience while managing suppliers, production teams, creative partners, technical crews, and on-site staff. Oversaw rehearsals, show calling, run-of-show management, risk mitigation, and live event operations to ensure flawless delivery across both event days.</a:t>
+            </a:r>
+          </a:p>
+          <a:p>
+            <a:r>
+              <a:rPr lang="en-US" sz="1100" dirty="0"/>
+              <a:t>Successfully delivered a high-end fashion and lifestyle experience that elevated the Darin Madani brand, generated significant media and influencer engagement, and created a memorable launch attended by leading personalities from the regional fashion and entertainment industry.</a:t>
+            </a:r>
+          </a:p>
+          <a:p>
+            <a:endParaRPr lang="en-US" sz="1100" dirty="0"/>
+          </a:p>
+        </p:txBody>
+      </p:sp>
+    </p:spTree>
+    <p:extLst>
+      <p:ext uri="{BB962C8B-B14F-4D97-AF65-F5344CB8AC3E}">
+        <p14:creationId xmlns:p14="http://schemas.microsoft.com/office/powerpoint/2010/main" val="3561657796"/>
       </p:ext>
     </p:extLst>
   </p:cSld>

</xml_diff>